<commit_message>
Smoke eval de retrieval como gate de regressao no CI
- eval/fixtures/: 12 documentos reais truncados (71KB, versionados) +
  6 perguntas gold, regeneraveis via scripts/build_eval_fixtures.py
- tests/test_eval_smoke.py: indexa as fixtures em collection isolada e
  falha se Recall@5 < 0.9 ou MRR < 0.7; teste dedicado protege a query
  decomposition (cobertura AMZN+META no top-5)
- CI: Qdrant como service container + cache de modelos HuggingFace
- Cases A/B re-executados com Llama 3.3 70B (cota renovada)
- README, APRESENTACAO e PPTX com os numeros finais (recall 1.00,
  MRR 0.875) e nota honesta: gold set ficou facil, proximo passo e
  expandi-lo

Co-Authored-By: Claude Fable 5 <noreply@anthropic.com>
</commit_message>
<xml_diff>
--- a/docs/apresentacao_legacy_case.pptx
+++ b/docs/apresentacao_legacy_case.pptx
@@ -2535,7 +2535,7 @@
                 <a:ea typeface="Cambria" pitchFamily="34" charset="-122"/>
                 <a:cs typeface="Cambria" pitchFamily="34" charset="-120"/>
               </a:rPr>
-              <a:t>0.96</a:t>
+              <a:t>1.00</a:t>
             </a:r>
             <a:endParaRPr lang="en-US" sz="2400" dirty="0"/>
           </a:p>
@@ -6211,7 +6211,7 @@
                 <a:ea typeface="Calibri" pitchFamily="34" charset="-122"/>
                 <a:cs typeface="Calibri" pitchFamily="34" charset="-120"/>
               </a:rPr>
-              <a:t>Embeddings + reranker multilíngues; pool 20→50; métricas do sistema real; grupos de docs alternativos</a:t>
+              <a:t>Embeddings + reranker multilíngues; pool 20→50; métricas do sistema real; query decomposition multi-empresa</a:t>
             </a:r>
             <a:endParaRPr lang="en-US" sz="1150" dirty="0"/>
           </a:p>
@@ -6318,7 +6318,7 @@
                 <a:ea typeface="Calibri" pitchFamily="34" charset="-122"/>
                 <a:cs typeface="Calibri" pitchFamily="34" charset="-120"/>
               </a:rPr>
-              <a:t>Recall@10 0.96, MRR 0.82, recusas 100%</a:t>
+              <a:t>Recall@10 1.00, MRR 0.875, respostas e recusas 100%. Eval de retrieval roda no CI como gate</a:t>
             </a:r>
             <a:endParaRPr lang="en-US" sz="1150" dirty="0"/>
           </a:p>
@@ -6537,7 +6537,7 @@
                 <a:ea typeface="Cambria" pitchFamily="34" charset="-122"/>
                 <a:cs typeface="Cambria" pitchFamily="34" charset="-120"/>
               </a:rPr>
-              <a:t>0.96</a:t>
+              <a:t>1.00</a:t>
             </a:r>
             <a:endParaRPr lang="en-US" sz="4000" dirty="0"/>
           </a:p>
@@ -6615,7 +6615,7 @@
                 <a:ea typeface="Calibri" pitchFamily="34" charset="-122"/>
                 <a:cs typeface="Calibri" pitchFamily="34" charset="-120"/>
               </a:rPr>
-              <a:t>documentos corretos entre os 10 primeiros</a:t>
+              <a:t>todos os documentos corretos no top-10</a:t>
             </a:r>
             <a:endParaRPr lang="en-US" sz="1150" dirty="0"/>
           </a:p>
@@ -6681,7 +6681,7 @@
                 <a:ea typeface="Cambria" pitchFamily="34" charset="-122"/>
                 <a:cs typeface="Cambria" pitchFamily="34" charset="-120"/>
               </a:rPr>
-              <a:t>0.82</a:t>
+              <a:t>0.875</a:t>
             </a:r>
             <a:endParaRPr lang="en-US" sz="4000" dirty="0"/>
           </a:p>
@@ -6969,7 +6969,7 @@
                 <a:ea typeface="Cambria" pitchFamily="34" charset="-122"/>
                 <a:cs typeface="Cambria" pitchFamily="34" charset="-120"/>
               </a:rPr>
-              <a:t>92%</a:t>
+              <a:t>100%</a:t>
             </a:r>
             <a:endParaRPr lang="en-US" sz="4000" dirty="0"/>
           </a:p>
@@ -7086,7 +7086,7 @@
                 <a:ea typeface="Calibri" pitchFamily="34" charset="-122"/>
                 <a:cs typeface="Calibri" pitchFamily="34" charset="-120"/>
               </a:rPr>
-              <a:t>Honestidade: a única falha restante é a pergunta que pede capex anual de duas empresas de uma vez (10-Ks gigantes competindo com dezenas de trimestrais). Taxa de resposta depende do LLM: 92% (70B) vs 58% (8B, recusa demais) — retrieval não muda.</a:t>
+              <a:t>Honestidade: recall 1.00 em 14 perguntas indica gold set fácil para o sistema atual — próximo passo é expandi-lo, não celebrar. Taxa de resposta depende do LLM: 100% (70B) vs 58% (8B) — retrieval não muda. Eval de retrieval vira gate no CI.</a:t>
             </a:r>
             <a:endParaRPr lang="en-US" sz="1100" dirty="0"/>
           </a:p>

</xml_diff>